<commit_message>
Ajusta cap.05 (formação genérica) e CTA K Controllers mais convidativo
- Cap.05: situação reflete pós-graduações existentes mas teoria pura
- K Controllers: texto mais convidativo, botão 'ENTRAR NA LISTA DE ESPERA'

Co-Authored-By: Claude Sonnet 4.6 <noreply@anthropic.com>
Claude-Session: https://claude.ai/code/session_012MaEbe7T6DRidYKbPU8MZp
</commit_message>
<xml_diff>
--- a/codigo-controller.pptx
+++ b/codigo-controller.pptx
@@ -3835,7 +3835,7 @@
                 <a:ea typeface="Calibri" pitchFamily="34" charset="-122"/>
                 <a:cs typeface="Calibri" pitchFamily="34" charset="-120"/>
               </a:rPr>
-              <a:t>Você estudou controladoria. Aprendeu DRE, balanço, fluxo de caixa. Chegou no escritório e descobriu que a lógica é outra. Ninguém te ensinou precificação de hora jurídica.</a:t>
+              <a:t>Existem pós-graduações em Controladoria Jurídica. Mas quando você chega no escritório, percebe que eram teoria pura. O que o dia a dia cobra — precificação, indicadores, gestão de equipe — nenhum curso te preparou para isso.</a:t>
             </a:r>
             <a:endParaRPr lang="en-US" sz="1250" dirty="0"/>
           </a:p>
@@ -4594,7 +4594,7 @@
                 <a:ea typeface="Calibri" pitchFamily="34" charset="-122"/>
                 <a:cs typeface="Calibri" pitchFamily="34" charset="-120"/>
               </a:rPr>
-              <a:t>Um espaço exclusivo para controllers jurídicos trocarem, crescerem e pararem de resolver tudo no escuro.</a:t>
+              <a:t>Estou abrindo um espaço pensado para quem atua em Controladoria Jurídica — para trocar experiências reais, crescer junto e parar de resolver tudo sozinho.</a:t>
             </a:r>
             <a:endParaRPr lang="en-US" sz="1250" dirty="0"/>
           </a:p>
@@ -4602,13 +4602,52 @@
       </p:sp>
       <p:sp>
         <p:nvSpPr>
-          <p:cNvPr id="14" name="Shape 12"/>
+          <p:cNvPr id="14" name="Text 12"/>
+          <p:cNvSpPr txBox="1"/>
+          <p:nvPr/>
+        </p:nvSpPr>
+        <p:spPr>
+          <a:xfrm>
+            <a:off x="5166360" y="2724912"/>
+            <a:ext cx="3429000" cy="347472"/>
+          </a:xfrm>
+          <a:prstGeom prst="rect">
+            <a:avLst/>
+          </a:prstGeom>
+          <a:noFill/>
+          <a:ln/>
+        </p:spPr>
+        <p:txBody>
+          <a:bodyPr wrap="square" lIns="0" tIns="0" rIns="0" bIns="0" rtlCol="0" anchor="ctr"/>
+          <a:lstStyle/>
+          <a:p>
+            <a:pPr algn="l" indent="0" marL="0">
+              <a:buNone/>
+            </a:pPr>
+            <a:r>
+              <a:rPr lang="en-US" sz="1100" i="1" dirty="0">
+                <a:solidFill>
+                  <a:srgbClr val="C9A97A"/>
+                </a:solidFill>
+                <a:latin typeface="Calibri" pitchFamily="34" charset="0"/>
+                <a:ea typeface="Calibri" pitchFamily="34" charset="-122"/>
+                <a:cs typeface="Calibri" pitchFamily="34" charset="-120"/>
+              </a:rPr>
+              <a:t>As primeiras vagas são para quem chegar primeiro.</a:t>
+            </a:r>
+            <a:endParaRPr lang="en-US" sz="1100" dirty="0"/>
+          </a:p>
+        </p:txBody>
+      </p:sp>
+      <p:sp>
+        <p:nvSpPr>
+          <p:cNvPr id="15" name="Shape 13"/>
           <p:cNvSpPr/>
           <p:nvPr/>
         </p:nvSpPr>
         <p:spPr>
           <a:xfrm>
-            <a:off x="5166360" y="2907792"/>
+            <a:off x="5166360" y="3154680"/>
             <a:ext cx="3429000" cy="566928"/>
           </a:xfrm>
           <a:prstGeom prst="rect">
@@ -4627,13 +4666,13 @@
       </p:sp>
       <p:sp>
         <p:nvSpPr>
-          <p:cNvPr id="15" name="Text 13"/>
-          <p:cNvSpPr txBox="1"/>
-          <p:nvPr/>
-        </p:nvSpPr>
-        <p:spPr>
-          <a:xfrm>
-            <a:off x="5166360" y="2907792"/>
+          <p:cNvPr id="16" name="Text 14"/>
+          <p:cNvSpPr txBox="1"/>
+          <p:nvPr/>
+        </p:nvSpPr>
+        <p:spPr>
+          <a:xfrm>
+            <a:off x="5166360" y="3154680"/>
             <a:ext cx="3429000" cy="566928"/>
           </a:xfrm>
           <a:prstGeom prst="rect">
@@ -4650,7 +4689,7 @@
               <a:buNone/>
             </a:pPr>
             <a:r>
-              <a:rPr lang="en-US" sz="1150" b="1" spc="100" kern="0" dirty="0">
+              <a:rPr lang="en-US" sz="1050" b="1" spc="100" kern="0" dirty="0">
                 <a:solidFill>
                   <a:srgbClr val="FFFFFF"/>
                 </a:solidFill>
@@ -4658,21 +4697,21 @@
                 <a:ea typeface="Calibri" pitchFamily="34" charset="-122"/>
                 <a:cs typeface="Calibri" pitchFamily="34" charset="-120"/>
               </a:rPr>
-              <a:t>QUERO ENTRAR NA LISTA</a:t>
-            </a:r>
-            <a:endParaRPr lang="en-US" sz="1150" dirty="0"/>
-          </a:p>
-        </p:txBody>
-      </p:sp>
-      <p:sp>
-        <p:nvSpPr>
-          <p:cNvPr id="16" name="Text 14"/>
-          <p:cNvSpPr txBox="1"/>
-          <p:nvPr/>
-        </p:nvSpPr>
-        <p:spPr>
-          <a:xfrm>
-            <a:off x="5166360" y="3611880"/>
+              <a:t>ENTRAR NA LISTA DE ESPERA</a:t>
+            </a:r>
+            <a:endParaRPr lang="en-US" sz="1050" dirty="0"/>
+          </a:p>
+        </p:txBody>
+      </p:sp>
+      <p:sp>
+        <p:nvSpPr>
+          <p:cNvPr id="17" name="Text 15"/>
+          <p:cNvSpPr txBox="1"/>
+          <p:nvPr/>
+        </p:nvSpPr>
+        <p:spPr>
+          <a:xfrm>
+            <a:off x="5166360" y="3840480"/>
             <a:ext cx="3429000" cy="274320"/>
           </a:xfrm>
           <a:prstGeom prst="rect">
@@ -4705,7 +4744,7 @@
       </p:sp>
       <p:sp>
         <p:nvSpPr>
-          <p:cNvPr id="17" name="Text 15"/>
+          <p:cNvPr id="18" name="Text 16"/>
           <p:cNvSpPr txBox="1"/>
           <p:nvPr/>
         </p:nvSpPr>

</xml_diff>

<commit_message>
feat: capa com convite K Controllers sutil + encerramento simplificado
- Capa: convite discreto ao K Controllers no canto inferior direito
- Slide 14: encerramento simples com identidade KARIA (sem painel K Controllers)
- Slide 5 (Cap 01): corrigido para focar em ausência de formação em gestão
- Slide 13 (Cap 05): corrigido para pós-graduações genéricas/teoria pura

Co-Authored-By: Claude Sonnet 4.6 <noreply@anthropic.com>
Claude-Session: https://claude.ai/code/session_012MaEbe7T6DRidYKbPU8MZp
</commit_message>
<xml_diff>
--- a/codigo-controller.pptx
+++ b/codigo-controller.pptx
@@ -2400,8 +2400,8 @@
         </p:nvSpPr>
         <p:spPr>
           <a:xfrm>
-            <a:off x="749808" y="4617720"/>
-            <a:ext cx="5029200" cy="457200"/>
+            <a:off x="749808" y="4526280"/>
+            <a:ext cx="5029200" cy="411480"/>
           </a:xfrm>
           <a:prstGeom prst="rect">
             <a:avLst/>
@@ -2451,6 +2451,109 @@
               <a:t>e a prática cobra.</a:t>
             </a:r>
             <a:endParaRPr lang="en-US" sz="1050" dirty="0"/>
+          </a:p>
+        </p:txBody>
+      </p:sp>
+      <p:sp>
+        <p:nvSpPr>
+          <p:cNvPr id="10" name="Shape 8"/>
+          <p:cNvSpPr/>
+          <p:nvPr/>
+        </p:nvSpPr>
+        <p:spPr>
+          <a:xfrm>
+            <a:off x="5029200" y="4315968"/>
+            <a:ext cx="3657600" cy="27432"/>
+          </a:xfrm>
+          <a:prstGeom prst="rect">
+            <a:avLst/>
+          </a:prstGeom>
+          <a:solidFill>
+            <a:srgbClr val="1E3A50"/>
+          </a:solidFill>
+          <a:ln w="12700">
+            <a:solidFill>
+              <a:srgbClr val="1E3A50"/>
+            </a:solidFill>
+            <a:prstDash val="solid"/>
+          </a:ln>
+        </p:spPr>
+      </p:sp>
+      <p:sp>
+        <p:nvSpPr>
+          <p:cNvPr id="11" name="Text 9"/>
+          <p:cNvSpPr txBox="1"/>
+          <p:nvPr/>
+        </p:nvSpPr>
+        <p:spPr>
+          <a:xfrm>
+            <a:off x="5029200" y="4370832"/>
+            <a:ext cx="3657600" cy="228600"/>
+          </a:xfrm>
+          <a:prstGeom prst="rect">
+            <a:avLst/>
+          </a:prstGeom>
+          <a:noFill/>
+          <a:ln/>
+        </p:spPr>
+        <p:txBody>
+          <a:bodyPr wrap="square" lIns="0" tIns="0" rIns="0" bIns="0" rtlCol="0" anchor="ctr"/>
+          <a:lstStyle/>
+          <a:p>
+            <a:pPr algn="r" indent="0" marL="0">
+              <a:buNone/>
+            </a:pPr>
+            <a:r>
+              <a:rPr lang="en-US" sz="800" b="1" spc="200" kern="0" dirty="0">
+                <a:solidFill>
+                  <a:srgbClr val="B87333"/>
+                </a:solidFill>
+                <a:latin typeface="Cinzel" pitchFamily="34" charset="0"/>
+                <a:ea typeface="Cinzel" pitchFamily="34" charset="-122"/>
+                <a:cs typeface="Cinzel" pitchFamily="34" charset="-120"/>
+              </a:rPr>
+              <a:t>K CONTROLLERS</a:t>
+            </a:r>
+            <a:endParaRPr lang="en-US" sz="800" dirty="0"/>
+          </a:p>
+        </p:txBody>
+      </p:sp>
+      <p:sp>
+        <p:nvSpPr>
+          <p:cNvPr id="12" name="Text 10"/>
+          <p:cNvSpPr txBox="1"/>
+          <p:nvPr/>
+        </p:nvSpPr>
+        <p:spPr>
+          <a:xfrm>
+            <a:off x="5029200" y="4608576"/>
+            <a:ext cx="3657600" cy="228600"/>
+          </a:xfrm>
+          <a:prstGeom prst="rect">
+            <a:avLst/>
+          </a:prstGeom>
+          <a:noFill/>
+          <a:ln/>
+        </p:spPr>
+        <p:txBody>
+          <a:bodyPr wrap="square" lIns="0" tIns="0" rIns="0" bIns="0" rtlCol="0" anchor="ctr"/>
+          <a:lstStyle/>
+          <a:p>
+            <a:pPr algn="r" indent="0" marL="0">
+              <a:buNone/>
+            </a:pPr>
+            <a:r>
+              <a:rPr lang="en-US" sz="850" dirty="0">
+                <a:solidFill>
+                  <a:srgbClr val="607080"/>
+                </a:solidFill>
+                <a:latin typeface="Calibri" pitchFamily="34" charset="0"/>
+                <a:ea typeface="Calibri" pitchFamily="34" charset="-122"/>
+                <a:cs typeface="Calibri" pitchFamily="34" charset="-120"/>
+              </a:rPr>
+              <a:t>Entre na lista de espera → kariagestao.com/k-controllers</a:t>
+            </a:r>
+            <a:endParaRPr lang="en-US" sz="850" dirty="0"/>
           </a:p>
         </p:txBody>
       </p:sp>
@@ -4182,31 +4285,6 @@
         <p:spPr>
           <a:xfrm>
             <a:off x="0" y="0"/>
-            <a:ext cx="4663440" cy="5143500"/>
-          </a:xfrm>
-          <a:prstGeom prst="rect">
-            <a:avLst/>
-          </a:prstGeom>
-          <a:solidFill>
-            <a:srgbClr val="1A3042"/>
-          </a:solidFill>
-          <a:ln w="12700">
-            <a:solidFill>
-              <a:srgbClr val="1A3042"/>
-            </a:solidFill>
-            <a:prstDash val="solid"/>
-          </a:ln>
-        </p:spPr>
-      </p:sp>
-      <p:sp>
-        <p:nvSpPr>
-          <p:cNvPr id="3" name="Shape 1"/>
-          <p:cNvSpPr/>
-          <p:nvPr/>
-        </p:nvSpPr>
-        <p:spPr>
-          <a:xfrm>
-            <a:off x="0" y="0"/>
             <a:ext cx="64008" cy="5143500"/>
           </a:xfrm>
           <a:prstGeom prst="rect">
@@ -4225,53 +4303,69 @@
       </p:sp>
       <p:sp>
         <p:nvSpPr>
-          <p:cNvPr id="4" name="Text 2"/>
-          <p:cNvSpPr txBox="1"/>
-          <p:nvPr/>
-        </p:nvSpPr>
-        <p:spPr>
-          <a:xfrm>
-            <a:off x="320040" y="777240"/>
-            <a:ext cx="4069080" cy="1280160"/>
-          </a:xfrm>
-          <a:prstGeom prst="rect">
-            <a:avLst/>
-          </a:prstGeom>
-          <a:noFill/>
-          <a:ln/>
-        </p:spPr>
-        <p:txBody>
-          <a:bodyPr wrap="square" lIns="0" tIns="0" rIns="0" bIns="0" rtlCol="0" anchor="ctr"/>
-          <a:lstStyle/>
-          <a:p>
-            <a:pPr algn="l" indent="0" marL="0">
-              <a:lnSpc>
-                <a:spcPct val="120000"/>
-              </a:lnSpc>
-              <a:buNone/>
-            </a:pPr>
-            <a:r>
-              <a:rPr lang="en-US" sz="2200" b="1" dirty="0">
-                <a:solidFill>
-                  <a:srgbClr val="FFFFFF"/>
+          <p:cNvPr id="3" name="Text 1"/>
+          <p:cNvSpPr txBox="1"/>
+          <p:nvPr/>
+        </p:nvSpPr>
+        <p:spPr>
+          <a:xfrm>
+            <a:off x="4389120" y="-1097280"/>
+            <a:ext cx="5303520" cy="7498080"/>
+          </a:xfrm>
+          <a:prstGeom prst="rect">
+            <a:avLst/>
+          </a:prstGeom>
+          <a:noFill/>
+          <a:ln/>
+        </p:spPr>
+        <p:txBody>
+          <a:bodyPr wrap="square" lIns="0" tIns="0" rIns="0" bIns="0" rtlCol="0" anchor="ctr"/>
+          <a:lstStyle/>
+          <a:p>
+            <a:pPr algn="l" indent="0" marL="0">
+              <a:buNone/>
+            </a:pPr>
+            <a:r>
+              <a:rPr lang="en-US" sz="36000" dirty="0">
+                <a:solidFill>
+                  <a:srgbClr val="0F2840"/>
                 </a:solidFill>
                 <a:latin typeface="Cinzel" pitchFamily="34" charset="0"/>
                 <a:ea typeface="Cinzel" pitchFamily="34" charset="-122"/>
                 <a:cs typeface="Cinzel" pitchFamily="34" charset="-120"/>
               </a:rPr>
-              <a:t>Controller Jurídico</a:t>
-            </a:r>
-            <a:endParaRPr lang="en-US" sz="2200" dirty="0"/>
-          </a:p>
-          <a:p>
-            <a:pPr algn="l" indent="0" marL="0">
-              <a:lnSpc>
-                <a:spcPct val="120000"/>
-              </a:lnSpc>
-              <a:buNone/>
-            </a:pPr>
-            <a:r>
-              <a:rPr lang="en-US" sz="2200" b="1" dirty="0">
+              <a:t>C</a:t>
+            </a:r>
+            <a:endParaRPr lang="en-US" sz="36000" dirty="0"/>
+          </a:p>
+        </p:txBody>
+      </p:sp>
+      <p:sp>
+        <p:nvSpPr>
+          <p:cNvPr id="4" name="Text 2"/>
+          <p:cNvSpPr txBox="1"/>
+          <p:nvPr/>
+        </p:nvSpPr>
+        <p:spPr>
+          <a:xfrm>
+            <a:off x="548640" y="1097280"/>
+            <a:ext cx="5486400" cy="640080"/>
+          </a:xfrm>
+          <a:prstGeom prst="rect">
+            <a:avLst/>
+          </a:prstGeom>
+          <a:noFill/>
+          <a:ln/>
+        </p:spPr>
+        <p:txBody>
+          <a:bodyPr wrap="square" lIns="0" tIns="0" rIns="0" bIns="0" rtlCol="0" anchor="ctr"/>
+          <a:lstStyle/>
+          <a:p>
+            <a:pPr algn="l" indent="0" marL="0">
+              <a:buNone/>
+            </a:pPr>
+            <a:r>
+              <a:rPr lang="en-US" sz="3000" b="1" dirty="0">
                 <a:solidFill>
                   <a:srgbClr val="FFFFFF"/>
                 </a:solidFill>
@@ -4279,9 +4373,9 @@
                 <a:ea typeface="Cinzel" pitchFamily="34" charset="-122"/>
                 <a:cs typeface="Cinzel" pitchFamily="34" charset="-120"/>
               </a:rPr>
-              <a:t>não trabalha sozinho.</a:t>
-            </a:r>
-            <a:endParaRPr lang="en-US" sz="2200" dirty="0"/>
+              <a:t>Você chegou até aqui.</a:t>
+            </a:r>
+            <a:endParaRPr lang="en-US" sz="3000" dirty="0"/>
           </a:p>
         </p:txBody>
       </p:sp>
@@ -4293,37 +4387,34 @@
         </p:nvSpPr>
         <p:spPr>
           <a:xfrm>
-            <a:off x="320040" y="2176272"/>
-            <a:ext cx="4069080" cy="914400"/>
-          </a:xfrm>
-          <a:prstGeom prst="rect">
-            <a:avLst/>
-          </a:prstGeom>
-          <a:noFill/>
-          <a:ln/>
-        </p:spPr>
-        <p:txBody>
-          <a:bodyPr wrap="square" lIns="0" tIns="0" rIns="0" bIns="0" rtlCol="0" anchor="ctr"/>
-          <a:lstStyle/>
-          <a:p>
-            <a:pPr algn="l" indent="0" marL="0">
-              <a:lnSpc>
-                <a:spcPct val="160000"/>
-              </a:lnSpc>
-              <a:buNone/>
-            </a:pPr>
-            <a:r>
-              <a:rPr lang="en-US" sz="1250" dirty="0">
-                <a:solidFill>
-                  <a:srgbClr val="F8F6F3"/>
+            <a:off x="548640" y="1783080"/>
+            <a:ext cx="5486400" cy="411480"/>
+          </a:xfrm>
+          <a:prstGeom prst="rect">
+            <a:avLst/>
+          </a:prstGeom>
+          <a:noFill/>
+          <a:ln/>
+        </p:spPr>
+        <p:txBody>
+          <a:bodyPr wrap="square" lIns="0" tIns="0" rIns="0" bIns="0" rtlCol="0" anchor="ctr"/>
+          <a:lstStyle/>
+          <a:p>
+            <a:pPr algn="l" indent="0" marL="0">
+              <a:buNone/>
+            </a:pPr>
+            <a:r>
+              <a:rPr lang="en-US" sz="1500" i="1" dirty="0">
+                <a:solidFill>
+                  <a:srgbClr val="C9A97A"/>
                 </a:solidFill>
                 <a:latin typeface="Calibri" pitchFamily="34" charset="0"/>
                 <a:ea typeface="Calibri" pitchFamily="34" charset="-122"/>
                 <a:cs typeface="Calibri" pitchFamily="34" charset="-120"/>
               </a:rPr>
-              <a:t>Se você chegou até aqui, já sabe que a profissão exige mais do que os cursos ensinam — exige trocar com quem vive o mesmo.</a:t>
-            </a:r>
-            <a:endParaRPr lang="en-US" sz="1250" dirty="0"/>
+              <a:t>Isso já diz muito sobre você.</a:t>
+            </a:r>
+            <a:endParaRPr lang="en-US" sz="1500" dirty="0"/>
           </a:p>
         </p:txBody>
       </p:sp>
@@ -4335,8 +4426,8 @@
         </p:nvSpPr>
         <p:spPr>
           <a:xfrm>
-            <a:off x="320040" y="3218688"/>
-            <a:ext cx="3474720" cy="27432"/>
+            <a:off x="548640" y="2331720"/>
+            <a:ext cx="4114800" cy="27432"/>
           </a:xfrm>
           <a:prstGeom prst="rect">
             <a:avLst/>
@@ -4360,96 +4451,80 @@
         </p:nvSpPr>
         <p:spPr>
           <a:xfrm>
-            <a:off x="320040" y="3310128"/>
-            <a:ext cx="3200400" cy="274320"/>
-          </a:xfrm>
-          <a:prstGeom prst="rect">
-            <a:avLst/>
-          </a:prstGeom>
-          <a:noFill/>
-          <a:ln/>
-        </p:spPr>
-        <p:txBody>
-          <a:bodyPr wrap="square" lIns="0" tIns="0" rIns="0" bIns="0" rtlCol="0" anchor="ctr"/>
-          <a:lstStyle/>
-          <a:p>
-            <a:pPr algn="l" indent="0" marL="0">
-              <a:buNone/>
-            </a:pPr>
-            <a:r>
-              <a:rPr lang="en-US" sz="1050" dirty="0">
-                <a:solidFill>
-                  <a:srgbClr val="C9A97A"/>
+            <a:off x="548640" y="2487168"/>
+            <a:ext cx="5943600" cy="914400"/>
+          </a:xfrm>
+          <a:prstGeom prst="rect">
+            <a:avLst/>
+          </a:prstGeom>
+          <a:noFill/>
+          <a:ln/>
+        </p:spPr>
+        <p:txBody>
+          <a:bodyPr wrap="square" lIns="0" tIns="0" rIns="0" bIns="0" rtlCol="0" anchor="ctr"/>
+          <a:lstStyle/>
+          <a:p>
+            <a:pPr algn="l" indent="0" marL="0">
+              <a:lnSpc>
+                <a:spcPct val="160000"/>
+              </a:lnSpc>
+              <a:buNone/>
+            </a:pPr>
+            <a:r>
+              <a:rPr lang="en-US" sz="1350" dirty="0">
+                <a:solidFill>
+                  <a:srgbClr val="F8F6F3"/>
                 </a:solidFill>
                 <a:latin typeface="Calibri" pitchFamily="34" charset="0"/>
                 <a:ea typeface="Calibri" pitchFamily="34" charset="-122"/>
                 <a:cs typeface="Calibri" pitchFamily="34" charset="-120"/>
               </a:rPr>
-              <a:t>kariagestao.com</a:t>
-            </a:r>
-            <a:endParaRPr lang="en-US" sz="1050" dirty="0"/>
-          </a:p>
-        </p:txBody>
-      </p:sp>
-      <p:sp>
-        <p:nvSpPr>
-          <p:cNvPr id="8" name="Text 6"/>
-          <p:cNvSpPr txBox="1"/>
-          <p:nvPr/>
-        </p:nvSpPr>
-        <p:spPr>
-          <a:xfrm>
-            <a:off x="320040" y="3630168"/>
-            <a:ext cx="3200400" cy="274320"/>
-          </a:xfrm>
-          <a:prstGeom prst="rect">
-            <a:avLst/>
-          </a:prstGeom>
-          <a:noFill/>
-          <a:ln/>
-        </p:spPr>
-        <p:txBody>
-          <a:bodyPr wrap="square" lIns="0" tIns="0" rIns="0" bIns="0" rtlCol="0" anchor="ctr"/>
-          <a:lstStyle/>
-          <a:p>
-            <a:pPr algn="l" indent="0" marL="0">
-              <a:buNone/>
-            </a:pPr>
-            <a:r>
-              <a:rPr lang="en-US" sz="1050" dirty="0">
-                <a:solidFill>
-                  <a:srgbClr val="607080"/>
+              <a:t>A Controladoria Jurídica não tem manual pronto.</a:t>
+            </a:r>
+            <a:endParaRPr lang="en-US" sz="1350" dirty="0"/>
+          </a:p>
+          <a:p>
+            <a:pPr algn="l" indent="0" marL="0">
+              <a:lnSpc>
+                <a:spcPct val="160000"/>
+              </a:lnSpc>
+              <a:buNone/>
+            </a:pPr>
+            <a:r>
+              <a:rPr lang="en-US" sz="1350" dirty="0">
+                <a:solidFill>
+                  <a:srgbClr val="F8F6F3"/>
                 </a:solidFill>
                 <a:latin typeface="Calibri" pitchFamily="34" charset="0"/>
                 <a:ea typeface="Calibri" pitchFamily="34" charset="-122"/>
                 <a:cs typeface="Calibri" pitchFamily="34" charset="-120"/>
               </a:rPr>
-              <a:t>contato@kariagestao.com</a:t>
-            </a:r>
-            <a:endParaRPr lang="en-US" sz="1050" dirty="0"/>
-          </a:p>
-        </p:txBody>
-      </p:sp>
-      <p:sp>
-        <p:nvSpPr>
-          <p:cNvPr id="9" name="Shape 7"/>
+              <a:t>Mas tem pessoas que escolheram construir o caminho com mais consciência.</a:t>
+            </a:r>
+            <a:endParaRPr lang="en-US" sz="1350" dirty="0"/>
+          </a:p>
+        </p:txBody>
+      </p:sp>
+      <p:sp>
+        <p:nvSpPr>
+          <p:cNvPr id="8" name="Shape 6"/>
           <p:cNvSpPr/>
           <p:nvPr/>
         </p:nvSpPr>
         <p:spPr>
           <a:xfrm>
-            <a:off x="4983480" y="594360"/>
-            <a:ext cx="3749040" cy="3977640"/>
+            <a:off x="548640" y="3547872"/>
+            <a:ext cx="4114800" cy="27432"/>
           </a:xfrm>
           <a:prstGeom prst="rect">
             <a:avLst/>
           </a:prstGeom>
           <a:solidFill>
-            <a:srgbClr val="0A1822"/>
+            <a:srgbClr val="1E3A50"/>
           </a:solidFill>
           <a:ln w="12700">
             <a:solidFill>
-              <a:srgbClr val="B87333"/>
+              <a:srgbClr val="1E3A50"/>
             </a:solidFill>
             <a:prstDash val="solid"/>
           </a:ln>
@@ -4457,327 +4532,79 @@
       </p:sp>
       <p:sp>
         <p:nvSpPr>
-          <p:cNvPr id="10" name="Text 8"/>
-          <p:cNvSpPr txBox="1"/>
-          <p:nvPr/>
-        </p:nvSpPr>
-        <p:spPr>
-          <a:xfrm>
-            <a:off x="5074920" y="621792"/>
-            <a:ext cx="777240" cy="822960"/>
-          </a:xfrm>
-          <a:prstGeom prst="rect">
-            <a:avLst/>
-          </a:prstGeom>
-          <a:noFill/>
-          <a:ln/>
-        </p:spPr>
-        <p:txBody>
-          <a:bodyPr wrap="square" lIns="0" tIns="0" rIns="0" bIns="0" rtlCol="0" anchor="ctr"/>
-          <a:lstStyle/>
-          <a:p>
-            <a:pPr algn="l" indent="0" marL="0">
-              <a:buNone/>
-            </a:pPr>
-            <a:r>
-              <a:rPr lang="en-US" sz="4200" b="1" dirty="0">
-                <a:solidFill>
-                  <a:srgbClr val="B87333"/>
-                </a:solidFill>
-                <a:latin typeface="Cinzel" pitchFamily="34" charset="0"/>
-                <a:ea typeface="Cinzel" pitchFamily="34" charset="-122"/>
-                <a:cs typeface="Cinzel" pitchFamily="34" charset="-120"/>
-              </a:rPr>
-              <a:t>K</a:t>
-            </a:r>
-            <a:endParaRPr lang="en-US" sz="4200" dirty="0"/>
-          </a:p>
-        </p:txBody>
-      </p:sp>
-      <p:sp>
-        <p:nvSpPr>
-          <p:cNvPr id="11" name="Text 9"/>
-          <p:cNvSpPr txBox="1"/>
-          <p:nvPr/>
-        </p:nvSpPr>
-        <p:spPr>
-          <a:xfrm>
-            <a:off x="5715000" y="713232"/>
-            <a:ext cx="2834640" cy="548640"/>
-          </a:xfrm>
-          <a:prstGeom prst="rect">
-            <a:avLst/>
-          </a:prstGeom>
-          <a:noFill/>
-          <a:ln/>
-        </p:spPr>
-        <p:txBody>
-          <a:bodyPr wrap="square" lIns="0" tIns="0" rIns="0" bIns="0" rtlCol="0" anchor="ctr"/>
-          <a:lstStyle/>
-          <a:p>
-            <a:pPr algn="l" indent="0" marL="0">
-              <a:buNone/>
-            </a:pPr>
-            <a:r>
-              <a:rPr lang="en-US" sz="1350" b="1" spc="150" kern="0" dirty="0">
-                <a:solidFill>
-                  <a:srgbClr val="FFFFFF"/>
-                </a:solidFill>
-                <a:latin typeface="Cinzel" pitchFamily="34" charset="0"/>
-                <a:ea typeface="Cinzel" pitchFamily="34" charset="-122"/>
-                <a:cs typeface="Cinzel" pitchFamily="34" charset="-120"/>
-              </a:rPr>
-              <a:t>CONTROLLERS</a:t>
-            </a:r>
-            <a:endParaRPr lang="en-US" sz="1350" dirty="0"/>
-          </a:p>
-        </p:txBody>
-      </p:sp>
-      <p:sp>
-        <p:nvSpPr>
-          <p:cNvPr id="12" name="Shape 10"/>
-          <p:cNvSpPr/>
-          <p:nvPr/>
-        </p:nvSpPr>
-        <p:spPr>
-          <a:xfrm>
-            <a:off x="5166360" y="1508760"/>
-            <a:ext cx="3429000" cy="27432"/>
-          </a:xfrm>
-          <a:prstGeom prst="rect">
-            <a:avLst/>
-          </a:prstGeom>
-          <a:solidFill>
-            <a:srgbClr val="B87333"/>
-          </a:solidFill>
-          <a:ln w="12700">
-            <a:solidFill>
-              <a:srgbClr val="B87333"/>
-            </a:solidFill>
-            <a:prstDash val="solid"/>
-          </a:ln>
-        </p:spPr>
-      </p:sp>
-      <p:sp>
-        <p:nvSpPr>
-          <p:cNvPr id="13" name="Text 11"/>
-          <p:cNvSpPr txBox="1"/>
-          <p:nvPr/>
-        </p:nvSpPr>
-        <p:spPr>
-          <a:xfrm>
-            <a:off x="5166360" y="1664208"/>
-            <a:ext cx="3429000" cy="1097280"/>
-          </a:xfrm>
-          <a:prstGeom prst="rect">
-            <a:avLst/>
-          </a:prstGeom>
-          <a:noFill/>
-          <a:ln/>
-        </p:spPr>
-        <p:txBody>
-          <a:bodyPr wrap="square" lIns="0" tIns="0" rIns="0" bIns="0" rtlCol="0" anchor="ctr"/>
-          <a:lstStyle/>
-          <a:p>
-            <a:pPr algn="l" indent="0" marL="0">
-              <a:lnSpc>
-                <a:spcPct val="155000"/>
-              </a:lnSpc>
-              <a:buNone/>
-            </a:pPr>
-            <a:r>
-              <a:rPr lang="en-US" sz="1250" dirty="0">
-                <a:solidFill>
-                  <a:srgbClr val="F8F6F3"/>
+          <p:cNvPr id="9" name="Text 7"/>
+          <p:cNvSpPr txBox="1"/>
+          <p:nvPr/>
+        </p:nvSpPr>
+        <p:spPr>
+          <a:xfrm>
+            <a:off x="548640" y="3639312"/>
+            <a:ext cx="5486400" cy="274320"/>
+          </a:xfrm>
+          <a:prstGeom prst="rect">
+            <a:avLst/>
+          </a:prstGeom>
+          <a:noFill/>
+          <a:ln/>
+        </p:spPr>
+        <p:txBody>
+          <a:bodyPr wrap="square" lIns="0" tIns="0" rIns="0" bIns="0" rtlCol="0" anchor="ctr"/>
+          <a:lstStyle/>
+          <a:p>
+            <a:pPr algn="l" indent="0" marL="0">
+              <a:buNone/>
+            </a:pPr>
+            <a:r>
+              <a:rPr lang="en-US" sz="1050" dirty="0">
+                <a:solidFill>
+                  <a:srgbClr val="607080"/>
                 </a:solidFill>
                 <a:latin typeface="Calibri" pitchFamily="34" charset="0"/>
                 <a:ea typeface="Calibri" pitchFamily="34" charset="-122"/>
                 <a:cs typeface="Calibri" pitchFamily="34" charset="-120"/>
               </a:rPr>
-              <a:t>Estou abrindo um espaço pensado para quem atua em Controladoria Jurídica — para trocar experiências reais, crescer junto e parar de resolver tudo sozinho.</a:t>
-            </a:r>
-            <a:endParaRPr lang="en-US" sz="1250" dirty="0"/>
-          </a:p>
-        </p:txBody>
-      </p:sp>
-      <p:sp>
-        <p:nvSpPr>
-          <p:cNvPr id="14" name="Text 12"/>
-          <p:cNvSpPr txBox="1"/>
-          <p:nvPr/>
-        </p:nvSpPr>
-        <p:spPr>
-          <a:xfrm>
-            <a:off x="5166360" y="2724912"/>
-            <a:ext cx="3429000" cy="347472"/>
-          </a:xfrm>
-          <a:prstGeom prst="rect">
-            <a:avLst/>
-          </a:prstGeom>
-          <a:noFill/>
-          <a:ln/>
-        </p:spPr>
-        <p:txBody>
-          <a:bodyPr wrap="square" lIns="0" tIns="0" rIns="0" bIns="0" rtlCol="0" anchor="ctr"/>
-          <a:lstStyle/>
-          <a:p>
-            <a:pPr algn="l" indent="0" marL="0">
-              <a:buNone/>
-            </a:pPr>
-            <a:r>
-              <a:rPr lang="en-US" sz="1100" i="1" dirty="0">
-                <a:solidFill>
-                  <a:srgbClr val="C9A97A"/>
+              <a:t>kariagestao.com  ·  contato@kariagestao.com</a:t>
+            </a:r>
+            <a:endParaRPr lang="en-US" sz="1050" dirty="0"/>
+          </a:p>
+        </p:txBody>
+      </p:sp>
+      <p:sp>
+        <p:nvSpPr>
+          <p:cNvPr id="10" name="Text 8"/>
+          <p:cNvSpPr txBox="1"/>
+          <p:nvPr/>
+        </p:nvSpPr>
+        <p:spPr>
+          <a:xfrm>
+            <a:off x="548640" y="3977640"/>
+            <a:ext cx="5486400" cy="256032"/>
+          </a:xfrm>
+          <a:prstGeom prst="rect">
+            <a:avLst/>
+          </a:prstGeom>
+          <a:noFill/>
+          <a:ln/>
+        </p:spPr>
+        <p:txBody>
+          <a:bodyPr wrap="square" lIns="0" tIns="0" rIns="0" bIns="0" rtlCol="0" anchor="ctr"/>
+          <a:lstStyle/>
+          <a:p>
+            <a:pPr algn="l" indent="0" marL="0">
+              <a:buNone/>
+            </a:pPr>
+            <a:r>
+              <a:rPr lang="en-US" sz="900" dirty="0">
+                <a:solidFill>
+                  <a:srgbClr val="304050"/>
                 </a:solidFill>
                 <a:latin typeface="Calibri" pitchFamily="34" charset="0"/>
                 <a:ea typeface="Calibri" pitchFamily="34" charset="-122"/>
                 <a:cs typeface="Calibri" pitchFamily="34" charset="-120"/>
               </a:rPr>
-              <a:t>As primeiras vagas são para quem chegar primeiro.</a:t>
-            </a:r>
-            <a:endParaRPr lang="en-US" sz="1100" dirty="0"/>
-          </a:p>
-        </p:txBody>
-      </p:sp>
-      <p:sp>
-        <p:nvSpPr>
-          <p:cNvPr id="15" name="Shape 13"/>
-          <p:cNvSpPr/>
-          <p:nvPr/>
-        </p:nvSpPr>
-        <p:spPr>
-          <a:xfrm>
-            <a:off x="5166360" y="3154680"/>
-            <a:ext cx="3429000" cy="566928"/>
-          </a:xfrm>
-          <a:prstGeom prst="rect">
-            <a:avLst/>
-          </a:prstGeom>
-          <a:solidFill>
-            <a:srgbClr val="B87333"/>
-          </a:solidFill>
-          <a:ln w="12700">
-            <a:solidFill>
-              <a:srgbClr val="B87333"/>
-            </a:solidFill>
-            <a:prstDash val="solid"/>
-          </a:ln>
-        </p:spPr>
-      </p:sp>
-      <p:sp>
-        <p:nvSpPr>
-          <p:cNvPr id="16" name="Text 14"/>
-          <p:cNvSpPr txBox="1"/>
-          <p:nvPr/>
-        </p:nvSpPr>
-        <p:spPr>
-          <a:xfrm>
-            <a:off x="5166360" y="3154680"/>
-            <a:ext cx="3429000" cy="566928"/>
-          </a:xfrm>
-          <a:prstGeom prst="rect">
-            <a:avLst/>
-          </a:prstGeom>
-          <a:noFill/>
-          <a:ln/>
-        </p:spPr>
-        <p:txBody>
-          <a:bodyPr wrap="square" lIns="0" tIns="0" rIns="0" bIns="0" rtlCol="0" anchor="ctr"/>
-          <a:lstStyle/>
-          <a:p>
-            <a:pPr algn="ctr" indent="0" marL="0">
-              <a:buNone/>
-            </a:pPr>
-            <a:r>
-              <a:rPr lang="en-US" sz="1050" b="1" spc="100" kern="0" dirty="0">
-                <a:solidFill>
-                  <a:srgbClr val="FFFFFF"/>
-                </a:solidFill>
-                <a:latin typeface="Calibri" pitchFamily="34" charset="0"/>
-                <a:ea typeface="Calibri" pitchFamily="34" charset="-122"/>
-                <a:cs typeface="Calibri" pitchFamily="34" charset="-120"/>
-              </a:rPr>
-              <a:t>ENTRAR NA LISTA DE ESPERA</a:t>
-            </a:r>
-            <a:endParaRPr lang="en-US" sz="1050" dirty="0"/>
-          </a:p>
-        </p:txBody>
-      </p:sp>
-      <p:sp>
-        <p:nvSpPr>
-          <p:cNvPr id="17" name="Text 15"/>
-          <p:cNvSpPr txBox="1"/>
-          <p:nvPr/>
-        </p:nvSpPr>
-        <p:spPr>
-          <a:xfrm>
-            <a:off x="5166360" y="3840480"/>
-            <a:ext cx="3429000" cy="274320"/>
-          </a:xfrm>
-          <a:prstGeom prst="rect">
-            <a:avLst/>
-          </a:prstGeom>
-          <a:noFill/>
-          <a:ln/>
-        </p:spPr>
-        <p:txBody>
-          <a:bodyPr wrap="square" lIns="0" tIns="0" rIns="0" bIns="0" rtlCol="0" anchor="ctr"/>
-          <a:lstStyle/>
-          <a:p>
-            <a:pPr algn="ctr" indent="0" marL="0">
-              <a:buNone/>
-            </a:pPr>
-            <a:r>
-              <a:rPr lang="en-US" sz="1000" dirty="0">
-                <a:solidFill>
-                  <a:srgbClr val="C9A97A"/>
-                </a:solidFill>
-                <a:latin typeface="Calibri" pitchFamily="34" charset="0"/>
-                <a:ea typeface="Calibri" pitchFamily="34" charset="-122"/>
-                <a:cs typeface="Calibri" pitchFamily="34" charset="-120"/>
-              </a:rPr>
-              <a:t>kariagestao.com/k-controllers</a:t>
-            </a:r>
-            <a:endParaRPr lang="en-US" sz="1000" dirty="0"/>
-          </a:p>
-        </p:txBody>
-      </p:sp>
-      <p:sp>
-        <p:nvSpPr>
-          <p:cNvPr id="18" name="Text 16"/>
-          <p:cNvSpPr txBox="1"/>
-          <p:nvPr/>
-        </p:nvSpPr>
-        <p:spPr>
-          <a:xfrm>
-            <a:off x="5166360" y="4160520"/>
-            <a:ext cx="3429000" cy="274320"/>
-          </a:xfrm>
-          <a:prstGeom prst="rect">
-            <a:avLst/>
-          </a:prstGeom>
-          <a:noFill/>
-          <a:ln/>
-        </p:spPr>
-        <p:txBody>
-          <a:bodyPr wrap="square" lIns="0" tIns="0" rIns="0" bIns="0" rtlCol="0" anchor="ctr"/>
-          <a:lstStyle/>
-          <a:p>
-            <a:pPr algn="ctr" indent="0" marL="0">
-              <a:buNone/>
-            </a:pPr>
-            <a:r>
-              <a:rPr lang="en-US" sz="850" dirty="0">
-                <a:solidFill>
-                  <a:srgbClr val="607080"/>
-                </a:solidFill>
-                <a:latin typeface="Calibri" pitchFamily="34" charset="0"/>
-                <a:ea typeface="Calibri" pitchFamily="34" charset="-122"/>
-                <a:cs typeface="Calibri" pitchFamily="34" charset="-120"/>
-              </a:rPr>
               <a:t>KARIA Gestão  ·  Gestão que entrega. Estratégia que transforma.</a:t>
             </a:r>
-            <a:endParaRPr lang="en-US" sz="850" dirty="0"/>
+            <a:endParaRPr lang="en-US" sz="900" dirty="0"/>
           </a:p>
         </p:txBody>
       </p:sp>

</xml_diff>